<commit_message>
added one more agent and made the routing robust also connected with the bitchat mesh
</commit_message>
<xml_diff>
--- a/docs/KH131.pptx
+++ b/docs/KH131.pptx
@@ -324,7 +324,7 @@
           <a:p>
             <a:fld id="{5BCAD085-E8A6-8845-BD4E-CB4CCA059FC4}" type="datetimeFigureOut">
               <a:rPr lang="en-US" smtClean="0"/>
-              <a:t>9/12/2026</a:t>
+              <a:t>9/15/2026</a:t>
             </a:fld>
             <a:endParaRPr lang="en-US"/>
           </a:p>
@@ -492,7 +492,7 @@
           <a:p>
             <a:fld id="{5BCAD085-E8A6-8845-BD4E-CB4CCA059FC4}" type="datetimeFigureOut">
               <a:rPr lang="en-US" smtClean="0"/>
-              <a:t>9/12/2026</a:t>
+              <a:t>9/15/2026</a:t>
             </a:fld>
             <a:endParaRPr lang="en-US"/>
           </a:p>
@@ -670,7 +670,7 @@
           <a:p>
             <a:fld id="{5BCAD085-E8A6-8845-BD4E-CB4CCA059FC4}" type="datetimeFigureOut">
               <a:rPr lang="en-US" smtClean="0"/>
-              <a:t>9/12/2026</a:t>
+              <a:t>9/15/2026</a:t>
             </a:fld>
             <a:endParaRPr lang="en-US"/>
           </a:p>
@@ -838,7 +838,7 @@
           <a:p>
             <a:fld id="{5BCAD085-E8A6-8845-BD4E-CB4CCA059FC4}" type="datetimeFigureOut">
               <a:rPr lang="en-US" smtClean="0"/>
-              <a:t>9/12/2026</a:t>
+              <a:t>9/15/2026</a:t>
             </a:fld>
             <a:endParaRPr lang="en-US"/>
           </a:p>
@@ -1083,7 +1083,7 @@
           <a:p>
             <a:fld id="{5BCAD085-E8A6-8845-BD4E-CB4CCA059FC4}" type="datetimeFigureOut">
               <a:rPr lang="en-US" smtClean="0"/>
-              <a:t>9/12/2026</a:t>
+              <a:t>9/15/2026</a:t>
             </a:fld>
             <a:endParaRPr lang="en-US"/>
           </a:p>
@@ -1368,7 +1368,7 @@
           <a:p>
             <a:fld id="{5BCAD085-E8A6-8845-BD4E-CB4CCA059FC4}" type="datetimeFigureOut">
               <a:rPr lang="en-US" smtClean="0"/>
-              <a:t>9/12/2026</a:t>
+              <a:t>9/15/2026</a:t>
             </a:fld>
             <a:endParaRPr lang="en-US"/>
           </a:p>
@@ -1787,7 +1787,7 @@
           <a:p>
             <a:fld id="{5BCAD085-E8A6-8845-BD4E-CB4CCA059FC4}" type="datetimeFigureOut">
               <a:rPr lang="en-US" smtClean="0"/>
-              <a:t>9/12/2026</a:t>
+              <a:t>9/15/2026</a:t>
             </a:fld>
             <a:endParaRPr lang="en-US"/>
           </a:p>
@@ -1904,7 +1904,7 @@
           <a:p>
             <a:fld id="{5BCAD085-E8A6-8845-BD4E-CB4CCA059FC4}" type="datetimeFigureOut">
               <a:rPr lang="en-US" smtClean="0"/>
-              <a:t>9/12/2026</a:t>
+              <a:t>9/15/2026</a:t>
             </a:fld>
             <a:endParaRPr lang="en-US"/>
           </a:p>
@@ -1999,7 +1999,7 @@
           <a:p>
             <a:fld id="{5BCAD085-E8A6-8845-BD4E-CB4CCA059FC4}" type="datetimeFigureOut">
               <a:rPr lang="en-US" smtClean="0"/>
-              <a:t>9/12/2026</a:t>
+              <a:t>9/15/2026</a:t>
             </a:fld>
             <a:endParaRPr lang="en-US"/>
           </a:p>
@@ -2274,7 +2274,7 @@
           <a:p>
             <a:fld id="{5BCAD085-E8A6-8845-BD4E-CB4CCA059FC4}" type="datetimeFigureOut">
               <a:rPr lang="en-US" smtClean="0"/>
-              <a:t>9/12/2026</a:t>
+              <a:t>9/15/2026</a:t>
             </a:fld>
             <a:endParaRPr lang="en-US"/>
           </a:p>
@@ -2526,7 +2526,7 @@
           <a:p>
             <a:fld id="{5BCAD085-E8A6-8845-BD4E-CB4CCA059FC4}" type="datetimeFigureOut">
               <a:rPr lang="en-US" smtClean="0"/>
-              <a:t>9/12/2026</a:t>
+              <a:t>9/15/2026</a:t>
             </a:fld>
             <a:endParaRPr lang="en-US"/>
           </a:p>
@@ -2737,7 +2737,7 @@
           <a:p>
             <a:fld id="{5BCAD085-E8A6-8845-BD4E-CB4CCA059FC4}" type="datetimeFigureOut">
               <a:rPr lang="en-US" smtClean="0"/>
-              <a:t>9/12/2026</a:t>
+              <a:t>9/15/2026</a:t>
             </a:fld>
             <a:endParaRPr lang="en-US"/>
           </a:p>
@@ -3128,62 +3128,53 @@
       </p:grpSpPr>
       <p:sp>
         <p:nvSpPr>
-          <p:cNvPr id="2" name="Rectangle 1">
+          <p:cNvPr id="4" name="TextBox 3">
             <a:extLst>
               <a:ext uri="{FF2B5EF4-FFF2-40B4-BE49-F238E27FC236}">
-                <a16:creationId xmlns:a16="http://schemas.microsoft.com/office/drawing/2014/main" id="{89993B58-8BFB-3A93-E11A-6676AB327311}"/>
+                <a16:creationId xmlns:a16="http://schemas.microsoft.com/office/drawing/2014/main" id="{3E0E6B10-C2E7-27E1-DB6E-C0914E91ACE6}"/>
               </a:ext>
             </a:extLst>
           </p:cNvPr>
-          <p:cNvSpPr/>
-          <p:nvPr/>
-        </p:nvSpPr>
-        <p:spPr>
-          <a:xfrm>
-            <a:off x="0" y="0"/>
-            <a:ext cx="82296" cy="6858000"/>
-          </a:xfrm>
-          <a:prstGeom prst="rect">
-            <a:avLst/>
-          </a:prstGeom>
-          <a:solidFill>
-            <a:srgbClr val="C9993F"/>
-          </a:solidFill>
-          <a:ln>
-            <a:solidFill>
-              <a:srgbClr val="C9993F"/>
-            </a:solidFill>
-          </a:ln>
-        </p:spPr>
-        <p:style>
-          <a:lnRef idx="1">
-            <a:schemeClr val="accent1"/>
-          </a:lnRef>
-          <a:fillRef idx="3">
-            <a:schemeClr val="accent1"/>
-          </a:fillRef>
-          <a:effectRef idx="2">
-            <a:schemeClr val="accent1"/>
-          </a:effectRef>
-          <a:fontRef idx="minor">
-            <a:schemeClr val="lt1"/>
-          </a:fontRef>
-        </p:style>
-        <p:txBody>
-          <a:bodyPr rtlCol="0" anchor="ctr"/>
+          <p:cNvSpPr txBox="1"/>
+          <p:nvPr/>
+        </p:nvSpPr>
+        <p:spPr>
+          <a:xfrm>
+            <a:off x="1936955" y="1140542"/>
+            <a:ext cx="8318091" cy="1107996"/>
+          </a:xfrm>
+          <a:prstGeom prst="rect">
+            <a:avLst/>
+          </a:prstGeom>
+          <a:noFill/>
+        </p:spPr>
+        <p:txBody>
+          <a:bodyPr wrap="square" rtlCol="0">
+            <a:spAutoFit/>
+          </a:bodyPr>
           <a:lstStyle/>
           <a:p>
             <a:pPr algn="ctr"/>
-            <a:endParaRPr/>
-          </a:p>
-        </p:txBody>
-      </p:sp>
-      <p:sp>
-        <p:nvSpPr>
-          <p:cNvPr id="9" name="TextBox 8">
+            <a:r>
+              <a:rPr lang="en-IN" sz="6600" b="1" dirty="0">
+                <a:solidFill>
+                  <a:schemeClr val="bg1"/>
+                </a:solidFill>
+                <a:latin typeface="ADLaM Display" panose="02010000000000000000" pitchFamily="2" charset="0"/>
+                <a:ea typeface="ADLaM Display" panose="02010000000000000000" pitchFamily="2" charset="0"/>
+                <a:cs typeface="ADLaM Display" panose="02010000000000000000" pitchFamily="2" charset="0"/>
+              </a:rPr>
+              <a:t>TEAM: KALA DHUA</a:t>
+            </a:r>
+          </a:p>
+        </p:txBody>
+      </p:sp>
+      <p:sp>
+        <p:nvSpPr>
+          <p:cNvPr id="5" name="TextBox 4">
             <a:extLst>
               <a:ext uri="{FF2B5EF4-FFF2-40B4-BE49-F238E27FC236}">
-                <a16:creationId xmlns:a16="http://schemas.microsoft.com/office/drawing/2014/main" id="{E5C52FE6-0B75-9931-3147-CF10F85BD50C}"/>
+                <a16:creationId xmlns:a16="http://schemas.microsoft.com/office/drawing/2014/main" id="{19FE95E6-EDE6-8837-6802-5348CEADFE18}"/>
               </a:ext>
             </a:extLst>
           </p:cNvPr>
@@ -3192,458 +3183,35 @@
         </p:nvSpPr>
         <p:spPr>
           <a:xfrm>
-            <a:off x="8412480" y="5943600"/>
-            <a:ext cx="3108960" cy="274320"/>
-          </a:xfrm>
-          <a:prstGeom prst="rect">
-            <a:avLst/>
-          </a:prstGeom>
-          <a:noFill/>
-        </p:spPr>
-        <p:txBody>
-          <a:bodyPr wrap="none" lIns="45720" rIns="45720">
-            <a:spAutoFit/>
-          </a:bodyPr>
-          <a:lstStyle/>
-          <a:p>
-            <a:pPr algn="r"/>
-            <a:r>
-              <a:rPr sz="1000" b="1" dirty="0">
-                <a:solidFill>
-                  <a:srgbClr val="F5EBD2"/>
-                </a:solidFill>
-                <a:latin typeface="Aptos"/>
-              </a:rPr>
-              <a:t>MIT ACSC • ALANDI, PUNE</a:t>
-            </a:r>
-          </a:p>
-        </p:txBody>
-      </p:sp>
-      <p:sp>
-        <p:nvSpPr>
-          <p:cNvPr id="15" name="Rectangle 14">
-            <a:extLst>
-              <a:ext uri="{FF2B5EF4-FFF2-40B4-BE49-F238E27FC236}">
-                <a16:creationId xmlns:a16="http://schemas.microsoft.com/office/drawing/2014/main" id="{05118B20-42EE-5815-E8AE-DBDA8F16EDFB}"/>
-              </a:ext>
-            </a:extLst>
-          </p:cNvPr>
-          <p:cNvSpPr/>
-          <p:nvPr/>
-        </p:nvSpPr>
-        <p:spPr>
-          <a:xfrm>
-            <a:off x="411480" y="1242345"/>
-            <a:ext cx="11338560" cy="13716"/>
-          </a:xfrm>
-          <a:prstGeom prst="rect">
-            <a:avLst/>
-          </a:prstGeom>
-          <a:solidFill>
-            <a:srgbClr val="8B5B24"/>
-          </a:solidFill>
-          <a:ln>
-            <a:solidFill>
-              <a:srgbClr val="8B5B24"/>
-            </a:solidFill>
-          </a:ln>
-        </p:spPr>
-        <p:style>
-          <a:lnRef idx="1">
-            <a:schemeClr val="accent1"/>
-          </a:lnRef>
-          <a:fillRef idx="3">
-            <a:schemeClr val="accent1"/>
-          </a:fillRef>
-          <a:effectRef idx="2">
-            <a:schemeClr val="accent1"/>
-          </a:effectRef>
-          <a:fontRef idx="minor">
-            <a:schemeClr val="lt1"/>
-          </a:fontRef>
-        </p:style>
-        <p:txBody>
-          <a:bodyPr rtlCol="0" anchor="ctr"/>
+            <a:off x="1936954" y="2959168"/>
+            <a:ext cx="8318091" cy="3139321"/>
+          </a:xfrm>
+          <a:prstGeom prst="rect">
+            <a:avLst/>
+          </a:prstGeom>
+          <a:noFill/>
+        </p:spPr>
+        <p:txBody>
+          <a:bodyPr wrap="square" rtlCol="0">
+            <a:spAutoFit/>
+          </a:bodyPr>
           <a:lstStyle/>
           <a:p>
             <a:pPr algn="ctr"/>
-            <a:endParaRPr sz="2000"/>
-          </a:p>
-        </p:txBody>
-      </p:sp>
-      <p:sp>
-        <p:nvSpPr>
-          <p:cNvPr id="16" name="Rectangle 15">
-            <a:extLst>
-              <a:ext uri="{FF2B5EF4-FFF2-40B4-BE49-F238E27FC236}">
-                <a16:creationId xmlns:a16="http://schemas.microsoft.com/office/drawing/2014/main" id="{CE2110AA-DA08-054C-C247-17907A3E759A}"/>
-              </a:ext>
-            </a:extLst>
-          </p:cNvPr>
-          <p:cNvSpPr/>
-          <p:nvPr/>
-        </p:nvSpPr>
-        <p:spPr>
-          <a:xfrm>
-            <a:off x="411480" y="6336792"/>
-            <a:ext cx="11338560" cy="9144"/>
-          </a:xfrm>
-          <a:prstGeom prst="rect">
-            <a:avLst/>
-          </a:prstGeom>
-          <a:solidFill>
-            <a:srgbClr val="8B5B24"/>
-          </a:solidFill>
-          <a:ln>
-            <a:solidFill>
-              <a:srgbClr val="8B5B24"/>
-            </a:solidFill>
-          </a:ln>
-        </p:spPr>
-        <p:style>
-          <a:lnRef idx="1">
-            <a:schemeClr val="accent1"/>
-          </a:lnRef>
-          <a:fillRef idx="3">
-            <a:schemeClr val="accent1"/>
-          </a:fillRef>
-          <a:effectRef idx="2">
-            <a:schemeClr val="accent1"/>
-          </a:effectRef>
-          <a:fontRef idx="minor">
-            <a:schemeClr val="lt1"/>
-          </a:fontRef>
-        </p:style>
-        <p:txBody>
-          <a:bodyPr rtlCol="0" anchor="ctr"/>
-          <a:lstStyle/>
-          <a:p>
-            <a:pPr algn="ctr"/>
-            <a:endParaRPr/>
-          </a:p>
-        </p:txBody>
-      </p:sp>
-      <p:sp>
-        <p:nvSpPr>
-          <p:cNvPr id="23" name="TextBox 22">
-            <a:extLst>
-              <a:ext uri="{FF2B5EF4-FFF2-40B4-BE49-F238E27FC236}">
-                <a16:creationId xmlns:a16="http://schemas.microsoft.com/office/drawing/2014/main" id="{22B82D12-CD86-6B70-CD13-20A38757FEAC}"/>
-              </a:ext>
-            </a:extLst>
-          </p:cNvPr>
-          <p:cNvSpPr txBox="1"/>
-          <p:nvPr/>
-        </p:nvSpPr>
-        <p:spPr>
-          <a:xfrm>
-            <a:off x="416719" y="321468"/>
-            <a:ext cx="4000500" cy="769441"/>
-          </a:xfrm>
-          <a:prstGeom prst="rect">
-            <a:avLst/>
-          </a:prstGeom>
-          <a:noFill/>
-        </p:spPr>
-        <p:txBody>
-          <a:bodyPr rot="0" spcFirstLastPara="0" vertOverflow="overflow" horzOverflow="overflow" vert="horz" wrap="square" lIns="91440" tIns="45720" rIns="91440" bIns="45720" numCol="1" spcCol="0" rtlCol="0" fromWordArt="0" anchor="t" anchorCtr="0" forceAA="0" compatLnSpc="1">
-            <a:prstTxWarp prst="textNoShape">
-              <a:avLst/>
-            </a:prstTxWarp>
-            <a:spAutoFit/>
-          </a:bodyPr>
-          <a:lstStyle/>
-          <a:p>
-            <a:r>
-              <a:rPr lang="en-US" sz="4400" b="1" i="0" u="none" strike="noStrike" baseline="0" dirty="0">
-                <a:solidFill>
-                  <a:srgbClr val="F5EBD2"/>
-                </a:solidFill>
-                <a:latin typeface="Angsana New"/>
-                <a:cs typeface="Angsana New"/>
-              </a:rPr>
-              <a:t>KURUKSHETRA 2.0</a:t>
-            </a:r>
-            <a:r>
-              <a:rPr sz="4400" b="0" i="0" dirty="0">
-                <a:solidFill>
-                  <a:srgbClr val="000000"/>
-                </a:solidFill>
-                <a:latin typeface="Aptos"/>
-                <a:ea typeface="Aptos"/>
-                <a:cs typeface="Aptos"/>
-              </a:rPr>
-              <a:t>​</a:t>
-            </a:r>
-            <a:endParaRPr lang="en-GB" sz="4400">
-              <a:ea typeface="Calibri"/>
-              <a:cs typeface="Calibri"/>
-            </a:endParaRPr>
-          </a:p>
-        </p:txBody>
-      </p:sp>
-      <p:sp>
-        <p:nvSpPr>
-          <p:cNvPr id="24" name="TextBox 23">
-            <a:extLst>
-              <a:ext uri="{FF2B5EF4-FFF2-40B4-BE49-F238E27FC236}">
-                <a16:creationId xmlns:a16="http://schemas.microsoft.com/office/drawing/2014/main" id="{6FB24EC9-2437-E6D2-E764-8F13A43BCA63}"/>
-              </a:ext>
-            </a:extLst>
-          </p:cNvPr>
-          <p:cNvSpPr txBox="1"/>
-          <p:nvPr/>
-        </p:nvSpPr>
-        <p:spPr>
-          <a:xfrm>
-            <a:off x="416718" y="785812"/>
-            <a:ext cx="2583656" cy="523220"/>
-          </a:xfrm>
-          <a:prstGeom prst="rect">
-            <a:avLst/>
-          </a:prstGeom>
-          <a:noFill/>
-        </p:spPr>
-        <p:txBody>
-          <a:bodyPr rot="0" spcFirstLastPara="0" vertOverflow="overflow" horzOverflow="overflow" vert="horz" wrap="square" lIns="91440" tIns="45720" rIns="91440" bIns="45720" numCol="1" spcCol="0" rtlCol="0" fromWordArt="0" anchor="t" anchorCtr="0" forceAA="0" compatLnSpc="1">
-            <a:prstTxWarp prst="textNoShape">
-              <a:avLst/>
-            </a:prstTxWarp>
-            <a:spAutoFit/>
-          </a:bodyPr>
-          <a:lstStyle/>
-          <a:p>
-            <a:r>
-              <a:rPr lang="en-US" sz="2800" b="1" dirty="0">
-                <a:solidFill>
-                  <a:srgbClr val="F5EBD2"/>
-                </a:solidFill>
-                <a:latin typeface="Angsana New"/>
-                <a:cs typeface="Angsana New"/>
-              </a:rPr>
-              <a:t>HACKFEST 2026</a:t>
-            </a:r>
-            <a:endParaRPr lang="en-GB" sz="2800" dirty="0">
-              <a:solidFill>
-                <a:srgbClr val="000000"/>
-              </a:solidFill>
-              <a:latin typeface="Angsana New"/>
-              <a:ea typeface="Calibri"/>
-              <a:cs typeface="Angsana New"/>
-            </a:endParaRPr>
-          </a:p>
-        </p:txBody>
-      </p:sp>
-      <p:sp>
-        <p:nvSpPr>
-          <p:cNvPr id="27" name="TextBox 26">
-            <a:extLst>
-              <a:ext uri="{FF2B5EF4-FFF2-40B4-BE49-F238E27FC236}">
-                <a16:creationId xmlns:a16="http://schemas.microsoft.com/office/drawing/2014/main" id="{E76271B5-90D8-35E3-21DA-EE0243877E51}"/>
-              </a:ext>
-            </a:extLst>
-          </p:cNvPr>
-          <p:cNvSpPr txBox="1"/>
-          <p:nvPr/>
-        </p:nvSpPr>
-        <p:spPr>
-          <a:xfrm>
-            <a:off x="419385" y="3392329"/>
-            <a:ext cx="6600847" cy="3046988"/>
-          </a:xfrm>
-          <a:prstGeom prst="rect">
-            <a:avLst/>
-          </a:prstGeom>
-          <a:noFill/>
-        </p:spPr>
-        <p:txBody>
-          <a:bodyPr wrap="square" lIns="45720" tIns="45720" rIns="45720" bIns="45720" anchor="t">
-            <a:spAutoFit/>
-          </a:bodyPr>
-          <a:lstStyle/>
-          <a:p>
-            <a:r>
-              <a:rPr lang="en-US" sz="3200" b="1" dirty="0">
-                <a:solidFill>
-                  <a:srgbClr val="F5EBD2"/>
-                </a:solidFill>
-                <a:latin typeface="Aptos"/>
-              </a:rPr>
-              <a:t>• PS20</a:t>
-            </a:r>
-            <a:br>
-              <a:rPr lang="en-US" sz="3200" b="1" dirty="0">
-                <a:latin typeface="Aptos"/>
-              </a:rPr>
-            </a:br>
-            <a:r>
-              <a:rPr lang="en-US" sz="3200" b="1" dirty="0">
-                <a:solidFill>
-                  <a:srgbClr val="F5EBD2"/>
-                </a:solidFill>
-                <a:latin typeface="Aptos"/>
-              </a:rPr>
-              <a:t>• </a:t>
-            </a:r>
-            <a:r>
-              <a:rPr lang="en-IN" sz="3200" b="1" dirty="0">
-                <a:solidFill>
-                  <a:schemeClr val="bg2">
-                    <a:lumMod val="90000"/>
-                  </a:schemeClr>
-                </a:solidFill>
-              </a:rPr>
-              <a:t>Agentic Disaster Relief &amp; Emergency Resource Coordinator</a:t>
-            </a:r>
-            <a:endParaRPr lang="en-US" sz="3200" b="1" dirty="0">
-              <a:solidFill>
-                <a:schemeClr val="bg2">
-                  <a:lumMod val="90000"/>
-                </a:schemeClr>
-              </a:solidFill>
-              <a:latin typeface="Aptos"/>
-            </a:endParaRPr>
-          </a:p>
-          <a:p>
-            <a:r>
-              <a:rPr lang="en-US" sz="3200" b="1" dirty="0">
-                <a:solidFill>
-                  <a:srgbClr val="F5EBD2"/>
-                </a:solidFill>
-                <a:latin typeface="Aptos"/>
-              </a:rPr>
-              <a:t>• Agentic Ai</a:t>
-            </a:r>
-            <a:endParaRPr lang="en-US" sz="3200" b="1" dirty="0">
-              <a:latin typeface="Aptos"/>
-            </a:endParaRPr>
-          </a:p>
-          <a:p>
-            <a:r>
-              <a:rPr lang="en-GB" sz="3200" b="1" dirty="0">
-                <a:solidFill>
-                  <a:srgbClr val="F5EBD2"/>
-                </a:solidFill>
-                <a:latin typeface="Aptos"/>
-              </a:rPr>
-              <a:t>• </a:t>
-            </a:r>
-            <a:r>
-              <a:rPr sz="3200" b="1" dirty="0">
-                <a:solidFill>
-                  <a:srgbClr val="F5EBD2"/>
-                </a:solidFill>
-                <a:latin typeface="Aptos"/>
-              </a:rPr>
-              <a:t> </a:t>
-            </a:r>
-            <a:r>
-              <a:rPr lang="en-US" sz="3200" b="1" dirty="0">
-                <a:solidFill>
-                  <a:srgbClr val="F5EBD2"/>
-                </a:solidFill>
-                <a:latin typeface="Aptos"/>
-              </a:rPr>
-              <a:t>KH131</a:t>
-            </a:r>
-            <a:br>
-              <a:rPr lang="en-GB" sz="3200" b="1" dirty="0">
-                <a:latin typeface="Aptos"/>
-              </a:rPr>
-            </a:br>
-            <a:r>
-              <a:rPr lang="en-US" sz="3200" b="1" dirty="0">
-                <a:solidFill>
-                  <a:srgbClr val="F5EBD2"/>
-                </a:solidFill>
-                <a:latin typeface="Aptos"/>
-              </a:rPr>
-              <a:t>•  Kala Dhua </a:t>
-            </a:r>
-            <a:endParaRPr lang="en-US" sz="3200" dirty="0">
-              <a:ea typeface="Calibri"/>
-              <a:cs typeface="Calibri"/>
-            </a:endParaRPr>
-          </a:p>
-        </p:txBody>
-      </p:sp>
-      <p:sp>
-        <p:nvSpPr>
-          <p:cNvPr id="30" name="TextBox 29">
-            <a:extLst>
-              <a:ext uri="{FF2B5EF4-FFF2-40B4-BE49-F238E27FC236}">
-                <a16:creationId xmlns:a16="http://schemas.microsoft.com/office/drawing/2014/main" id="{38824ED2-4033-0CA5-38FA-81EBB0D17285}"/>
-              </a:ext>
-            </a:extLst>
-          </p:cNvPr>
-          <p:cNvSpPr txBox="1"/>
-          <p:nvPr/>
-        </p:nvSpPr>
-        <p:spPr>
-          <a:xfrm>
-            <a:off x="8384538" y="332790"/>
-            <a:ext cx="3810001" cy="707886"/>
-          </a:xfrm>
-          <a:prstGeom prst="rect">
-            <a:avLst/>
-          </a:prstGeom>
-          <a:noFill/>
-        </p:spPr>
-        <p:txBody>
-          <a:bodyPr rot="0" spcFirstLastPara="0" vertOverflow="overflow" horzOverflow="overflow" vert="horz" wrap="square" lIns="91440" tIns="45720" rIns="91440" bIns="45720" numCol="1" spcCol="0" rtlCol="0" fromWordArt="0" anchor="t" anchorCtr="0" forceAA="0" compatLnSpc="1">
-            <a:prstTxWarp prst="textNoShape">
-              <a:avLst/>
-            </a:prstTxWarp>
-            <a:spAutoFit/>
-          </a:bodyPr>
-          <a:lstStyle/>
-          <a:p>
-            <a:pPr marL="0" indent="0" algn="ctr" rtl="0"/>
-            <a:r>
-              <a:rPr lang="en-US" sz="4000" b="1" kern="1200" dirty="0" err="1">
-                <a:solidFill>
-                  <a:srgbClr val="F5EBD2"/>
-                </a:solidFill>
-                <a:latin typeface="Times New Roman"/>
-                <a:ea typeface="ＭＳ Ｐゴシック"/>
-                <a:cs typeface="Times New Roman"/>
-              </a:rPr>
-              <a:t>DisruptionOps</a:t>
-            </a:r>
-            <a:endParaRPr lang="en-GB" sz="1600" dirty="0"/>
-          </a:p>
-        </p:txBody>
-      </p:sp>
-      <p:pic>
-        <p:nvPicPr>
-          <p:cNvPr id="22" name="Picture 21">
-            <a:extLst>
-              <a:ext uri="{FF2B5EF4-FFF2-40B4-BE49-F238E27FC236}">
-                <a16:creationId xmlns:a16="http://schemas.microsoft.com/office/drawing/2014/main" id="{4AF999F9-4F39-DB5F-F97A-7C663F7650F6}"/>
-              </a:ext>
-            </a:extLst>
-          </p:cNvPr>
-          <p:cNvPicPr>
-            <a:picLocks noChangeAspect="1"/>
-          </p:cNvPicPr>
-          <p:nvPr/>
-        </p:nvPicPr>
-        <p:blipFill>
-          <a:blip r:embed="rId2"/>
-          <a:stretch>
-            <a:fillRect/>
-          </a:stretch>
-        </p:blipFill>
-        <p:spPr>
-          <a:xfrm>
-            <a:off x="6701790" y="1374933"/>
-            <a:ext cx="4819650" cy="4695825"/>
-          </a:xfrm>
-          <a:prstGeom prst="rect">
-            <a:avLst/>
-          </a:prstGeom>
-        </p:spPr>
-      </p:pic>
+            <a:r>
+              <a:rPr lang="en-IN" sz="6600" b="1" dirty="0">
+                <a:solidFill>
+                  <a:schemeClr val="bg1"/>
+                </a:solidFill>
+                <a:latin typeface="ADLaM Display" panose="02010000000000000000" pitchFamily="2" charset="0"/>
+                <a:ea typeface="ADLaM Display" panose="02010000000000000000" pitchFamily="2" charset="0"/>
+                <a:cs typeface="ADLaM Display" panose="02010000000000000000" pitchFamily="2" charset="0"/>
+              </a:rPr>
+              <a:t>AGENTIC DISASTER MANAGEMENT SYSTEM</a:t>
+            </a:r>
+          </a:p>
+        </p:txBody>
+      </p:sp>
     </p:spTree>
     <p:extLst>
       <p:ext uri="{BB962C8B-B14F-4D97-AF65-F5344CB8AC3E}">
@@ -3742,47 +3310,6 @@
       </p:sp>
       <p:sp>
         <p:nvSpPr>
-          <p:cNvPr id="9" name="TextBox 8">
-            <a:extLst>
-              <a:ext uri="{FF2B5EF4-FFF2-40B4-BE49-F238E27FC236}">
-                <a16:creationId xmlns:a16="http://schemas.microsoft.com/office/drawing/2014/main" id="{D3211249-0C38-4387-DBB7-023065A05C12}"/>
-              </a:ext>
-            </a:extLst>
-          </p:cNvPr>
-          <p:cNvSpPr txBox="1"/>
-          <p:nvPr/>
-        </p:nvSpPr>
-        <p:spPr>
-          <a:xfrm>
-            <a:off x="10067449" y="6348414"/>
-            <a:ext cx="1680211" cy="246221"/>
-          </a:xfrm>
-          <a:prstGeom prst="rect">
-            <a:avLst/>
-          </a:prstGeom>
-          <a:noFill/>
-        </p:spPr>
-        <p:txBody>
-          <a:bodyPr wrap="square" lIns="45720" rIns="45720">
-            <a:spAutoFit/>
-          </a:bodyPr>
-          <a:lstStyle/>
-          <a:p>
-            <a:pPr algn="r"/>
-            <a:r>
-              <a:rPr sz="1000" b="1" dirty="0">
-                <a:solidFill>
-                  <a:srgbClr val="F5EBD2"/>
-                </a:solidFill>
-                <a:latin typeface="Aptos"/>
-              </a:rPr>
-              <a:t>MIT ACSC • ALANDI, PUNE</a:t>
-            </a:r>
-          </a:p>
-        </p:txBody>
-      </p:sp>
-      <p:sp>
-        <p:nvSpPr>
           <p:cNvPr id="3" name="TextBox 2">
             <a:extLst>
               <a:ext uri="{FF2B5EF4-FFF2-40B4-BE49-F238E27FC236}">
@@ -3867,36 +3394,6 @@
           </a:p>
         </p:txBody>
       </p:sp>
-      <p:pic>
-        <p:nvPicPr>
-          <p:cNvPr id="6" name="Picture 5">
-            <a:extLst>
-              <a:ext uri="{FF2B5EF4-FFF2-40B4-BE49-F238E27FC236}">
-                <a16:creationId xmlns:a16="http://schemas.microsoft.com/office/drawing/2014/main" id="{EDBC07A7-6E92-61AB-E8E7-24FD06CC1D33}"/>
-              </a:ext>
-            </a:extLst>
-          </p:cNvPr>
-          <p:cNvPicPr>
-            <a:picLocks noChangeAspect="1"/>
-          </p:cNvPicPr>
-          <p:nvPr/>
-        </p:nvPicPr>
-        <p:blipFill>
-          <a:blip r:embed="rId2"/>
-          <a:stretch>
-            <a:fillRect/>
-          </a:stretch>
-        </p:blipFill>
-        <p:spPr>
-          <a:xfrm>
-            <a:off x="11201014" y="64989"/>
-            <a:ext cx="884876" cy="894436"/>
-          </a:xfrm>
-          <a:prstGeom prst="rect">
-            <a:avLst/>
-          </a:prstGeom>
-        </p:spPr>
-      </p:pic>
       <p:sp>
         <p:nvSpPr>
           <p:cNvPr id="31" name="TextBox 30"/>
@@ -6071,7 +5568,7 @@
           <p:nvPr/>
         </p:nvPicPr>
         <p:blipFill>
-          <a:blip r:embed="rId3"/>
+          <a:blip r:embed="rId2"/>
           <a:stretch>
             <a:fillRect/>
           </a:stretch>
@@ -6101,7 +5598,7 @@
           <p:nvPr/>
         </p:nvPicPr>
         <p:blipFill>
-          <a:blip r:embed="rId4"/>
+          <a:blip r:embed="rId3"/>
           <a:stretch>
             <a:fillRect/>
           </a:stretch>
@@ -6131,7 +5628,7 @@
           <p:nvPr/>
         </p:nvPicPr>
         <p:blipFill>
-          <a:blip r:embed="rId5"/>
+          <a:blip r:embed="rId4"/>
           <a:stretch>
             <a:fillRect/>
           </a:stretch>
@@ -6256,47 +5753,6 @@
       </p:sp>
       <p:sp>
         <p:nvSpPr>
-          <p:cNvPr id="9" name="TextBox 8">
-            <a:extLst>
-              <a:ext uri="{FF2B5EF4-FFF2-40B4-BE49-F238E27FC236}">
-                <a16:creationId xmlns:a16="http://schemas.microsoft.com/office/drawing/2014/main" id="{DFEAA090-14B8-5A41-234A-AC8BFEF1DCAC}"/>
-              </a:ext>
-            </a:extLst>
-          </p:cNvPr>
-          <p:cNvSpPr txBox="1"/>
-          <p:nvPr/>
-        </p:nvSpPr>
-        <p:spPr>
-          <a:xfrm>
-            <a:off x="10067449" y="6348414"/>
-            <a:ext cx="1680211" cy="246221"/>
-          </a:xfrm>
-          <a:prstGeom prst="rect">
-            <a:avLst/>
-          </a:prstGeom>
-          <a:noFill/>
-        </p:spPr>
-        <p:txBody>
-          <a:bodyPr wrap="square" lIns="45720" rIns="45720">
-            <a:spAutoFit/>
-          </a:bodyPr>
-          <a:lstStyle/>
-          <a:p>
-            <a:pPr algn="r"/>
-            <a:r>
-              <a:rPr sz="1000" b="1" dirty="0">
-                <a:solidFill>
-                  <a:srgbClr val="F5EBD2"/>
-                </a:solidFill>
-                <a:latin typeface="Aptos"/>
-              </a:rPr>
-              <a:t>MIT ACSC • ALANDI, PUNE</a:t>
-            </a:r>
-          </a:p>
-        </p:txBody>
-      </p:sp>
-      <p:sp>
-        <p:nvSpPr>
           <p:cNvPr id="16" name="Rectangle 15">
             <a:extLst>
               <a:ext uri="{FF2B5EF4-FFF2-40B4-BE49-F238E27FC236}">
@@ -9002,77 +8458,6 @@
       </p:sp>
       <p:sp>
         <p:nvSpPr>
-          <p:cNvPr id="9" name="TextBox 8">
-            <a:extLst>
-              <a:ext uri="{FF2B5EF4-FFF2-40B4-BE49-F238E27FC236}">
-                <a16:creationId xmlns:a16="http://schemas.microsoft.com/office/drawing/2014/main" id="{4D61652D-EFD9-C159-7845-FF1EC81E427A}"/>
-              </a:ext>
-            </a:extLst>
-          </p:cNvPr>
-          <p:cNvSpPr txBox="1"/>
-          <p:nvPr/>
-        </p:nvSpPr>
-        <p:spPr>
-          <a:xfrm>
-            <a:off x="10067449" y="6348414"/>
-            <a:ext cx="1680211" cy="646331"/>
-          </a:xfrm>
-          <a:prstGeom prst="rect">
-            <a:avLst/>
-          </a:prstGeom>
-          <a:noFill/>
-        </p:spPr>
-        <p:txBody>
-          <a:bodyPr wrap="square" lIns="45720" rIns="45720">
-            <a:spAutoFit/>
-          </a:bodyPr>
-          <a:lstStyle/>
-          <a:p>
-            <a:pPr algn="r"/>
-            <a:r>
-              <a:rPr b="1" dirty="0">
-                <a:solidFill>
-                  <a:srgbClr val="F5EBD2"/>
-                </a:solidFill>
-                <a:latin typeface="Aptos"/>
-              </a:rPr>
-              <a:t>MIT ACSC • ALANDI, PUNE</a:t>
-            </a:r>
-          </a:p>
-        </p:txBody>
-      </p:sp>
-      <p:pic>
-        <p:nvPicPr>
-          <p:cNvPr id="22" name="Picture 21">
-            <a:extLst>
-              <a:ext uri="{FF2B5EF4-FFF2-40B4-BE49-F238E27FC236}">
-                <a16:creationId xmlns:a16="http://schemas.microsoft.com/office/drawing/2014/main" id="{B5B4B6A4-173B-63E9-C843-92755B590EA3}"/>
-              </a:ext>
-            </a:extLst>
-          </p:cNvPr>
-          <p:cNvPicPr>
-            <a:picLocks noChangeAspect="1"/>
-          </p:cNvPicPr>
-          <p:nvPr/>
-        </p:nvPicPr>
-        <p:blipFill>
-          <a:blip r:embed="rId2"/>
-          <a:stretch>
-            <a:fillRect/>
-          </a:stretch>
-        </p:blipFill>
-        <p:spPr>
-          <a:xfrm>
-            <a:off x="11201014" y="64989"/>
-            <a:ext cx="884876" cy="894436"/>
-          </a:xfrm>
-          <a:prstGeom prst="rect">
-            <a:avLst/>
-          </a:prstGeom>
-        </p:spPr>
-      </p:pic>
-      <p:sp>
-        <p:nvSpPr>
           <p:cNvPr id="3" name="TextBox 2">
             <a:extLst>
               <a:ext uri="{FF2B5EF4-FFF2-40B4-BE49-F238E27FC236}">
@@ -12330,77 +11715,6 @@
       </p:sp>
       <p:sp>
         <p:nvSpPr>
-          <p:cNvPr id="9" name="TextBox 8">
-            <a:extLst>
-              <a:ext uri="{FF2B5EF4-FFF2-40B4-BE49-F238E27FC236}">
-                <a16:creationId xmlns:a16="http://schemas.microsoft.com/office/drawing/2014/main" id="{4D61652D-EFD9-C159-7845-FF1EC81E427A}"/>
-              </a:ext>
-            </a:extLst>
-          </p:cNvPr>
-          <p:cNvSpPr txBox="1"/>
-          <p:nvPr/>
-        </p:nvSpPr>
-        <p:spPr>
-          <a:xfrm>
-            <a:off x="10067449" y="6348414"/>
-            <a:ext cx="1680211" cy="523220"/>
-          </a:xfrm>
-          <a:prstGeom prst="rect">
-            <a:avLst/>
-          </a:prstGeom>
-          <a:noFill/>
-        </p:spPr>
-        <p:txBody>
-          <a:bodyPr wrap="square" lIns="45720" rIns="45720">
-            <a:spAutoFit/>
-          </a:bodyPr>
-          <a:lstStyle/>
-          <a:p>
-            <a:pPr algn="r"/>
-            <a:r>
-              <a:rPr sz="1400" b="1" dirty="0">
-                <a:solidFill>
-                  <a:srgbClr val="F5EBD2"/>
-                </a:solidFill>
-                <a:latin typeface="Aptos"/>
-              </a:rPr>
-              <a:t>MIT ACSC • ALANDI, PUNE</a:t>
-            </a:r>
-          </a:p>
-        </p:txBody>
-      </p:sp>
-      <p:pic>
-        <p:nvPicPr>
-          <p:cNvPr id="22" name="Picture 21">
-            <a:extLst>
-              <a:ext uri="{FF2B5EF4-FFF2-40B4-BE49-F238E27FC236}">
-                <a16:creationId xmlns:a16="http://schemas.microsoft.com/office/drawing/2014/main" id="{B5B4B6A4-173B-63E9-C843-92755B590EA3}"/>
-              </a:ext>
-            </a:extLst>
-          </p:cNvPr>
-          <p:cNvPicPr>
-            <a:picLocks noChangeAspect="1"/>
-          </p:cNvPicPr>
-          <p:nvPr/>
-        </p:nvPicPr>
-        <p:blipFill>
-          <a:blip r:embed="rId2"/>
-          <a:stretch>
-            <a:fillRect/>
-          </a:stretch>
-        </p:blipFill>
-        <p:spPr>
-          <a:xfrm>
-            <a:off x="11201014" y="64989"/>
-            <a:ext cx="884876" cy="894436"/>
-          </a:xfrm>
-          <a:prstGeom prst="rect">
-            <a:avLst/>
-          </a:prstGeom>
-        </p:spPr>
-      </p:pic>
-      <p:sp>
-        <p:nvSpPr>
           <p:cNvPr id="3" name="TextBox 2">
             <a:extLst>
               <a:ext uri="{FF2B5EF4-FFF2-40B4-BE49-F238E27FC236}">
@@ -14470,47 +13784,6 @@
       </p:sp>
       <p:sp>
         <p:nvSpPr>
-          <p:cNvPr id="9" name="TextBox 8">
-            <a:extLst>
-              <a:ext uri="{FF2B5EF4-FFF2-40B4-BE49-F238E27FC236}">
-                <a16:creationId xmlns:a16="http://schemas.microsoft.com/office/drawing/2014/main" id="{3AE5BABB-C31F-CA82-909D-0726D67C0F4D}"/>
-              </a:ext>
-            </a:extLst>
-          </p:cNvPr>
-          <p:cNvSpPr txBox="1"/>
-          <p:nvPr/>
-        </p:nvSpPr>
-        <p:spPr>
-          <a:xfrm>
-            <a:off x="10067449" y="6348414"/>
-            <a:ext cx="1680211" cy="461665"/>
-          </a:xfrm>
-          <a:prstGeom prst="rect">
-            <a:avLst/>
-          </a:prstGeom>
-          <a:noFill/>
-        </p:spPr>
-        <p:txBody>
-          <a:bodyPr wrap="square" lIns="45720" rIns="45720">
-            <a:spAutoFit/>
-          </a:bodyPr>
-          <a:lstStyle/>
-          <a:p>
-            <a:pPr algn="r"/>
-            <a:r>
-              <a:rPr sz="1200" b="1" dirty="0">
-                <a:solidFill>
-                  <a:srgbClr val="F5EBD2"/>
-                </a:solidFill>
-                <a:latin typeface="Aptos"/>
-              </a:rPr>
-              <a:t>MIT ACSC • ALANDI, PUNE</a:t>
-            </a:r>
-          </a:p>
-        </p:txBody>
-      </p:sp>
-      <p:sp>
-        <p:nvSpPr>
           <p:cNvPr id="3" name="TextBox 2">
             <a:extLst>
               <a:ext uri="{FF2B5EF4-FFF2-40B4-BE49-F238E27FC236}">
@@ -14595,36 +13868,6 @@
           </a:p>
         </p:txBody>
       </p:sp>
-      <p:pic>
-        <p:nvPicPr>
-          <p:cNvPr id="6" name="Picture 5">
-            <a:extLst>
-              <a:ext uri="{FF2B5EF4-FFF2-40B4-BE49-F238E27FC236}">
-                <a16:creationId xmlns:a16="http://schemas.microsoft.com/office/drawing/2014/main" id="{8A1211F6-F2DB-7378-C1DC-D150E4B005C0}"/>
-              </a:ext>
-            </a:extLst>
-          </p:cNvPr>
-          <p:cNvPicPr>
-            <a:picLocks noChangeAspect="1"/>
-          </p:cNvPicPr>
-          <p:nvPr/>
-        </p:nvPicPr>
-        <p:blipFill>
-          <a:blip r:embed="rId2"/>
-          <a:stretch>
-            <a:fillRect/>
-          </a:stretch>
-        </p:blipFill>
-        <p:spPr>
-          <a:xfrm>
-            <a:off x="11201014" y="64989"/>
-            <a:ext cx="884876" cy="894436"/>
-          </a:xfrm>
-          <a:prstGeom prst="rect">
-            <a:avLst/>
-          </a:prstGeom>
-        </p:spPr>
-      </p:pic>
       <p:sp>
         <p:nvSpPr>
           <p:cNvPr id="31" name="TextBox 30"/>
@@ -16936,47 +16179,6 @@
       </p:sp>
       <p:sp>
         <p:nvSpPr>
-          <p:cNvPr id="9" name="TextBox 8">
-            <a:extLst>
-              <a:ext uri="{FF2B5EF4-FFF2-40B4-BE49-F238E27FC236}">
-                <a16:creationId xmlns:a16="http://schemas.microsoft.com/office/drawing/2014/main" id="{3AE5BABB-C31F-CA82-909D-0726D67C0F4D}"/>
-              </a:ext>
-            </a:extLst>
-          </p:cNvPr>
-          <p:cNvSpPr txBox="1"/>
-          <p:nvPr/>
-        </p:nvSpPr>
-        <p:spPr>
-          <a:xfrm>
-            <a:off x="10067449" y="6348414"/>
-            <a:ext cx="1680211" cy="584775"/>
-          </a:xfrm>
-          <a:prstGeom prst="rect">
-            <a:avLst/>
-          </a:prstGeom>
-          <a:noFill/>
-        </p:spPr>
-        <p:txBody>
-          <a:bodyPr wrap="square" lIns="45720" rIns="45720">
-            <a:spAutoFit/>
-          </a:bodyPr>
-          <a:lstStyle/>
-          <a:p>
-            <a:pPr algn="r"/>
-            <a:r>
-              <a:rPr sz="1600" b="1" dirty="0">
-                <a:solidFill>
-                  <a:srgbClr val="F5EBD2"/>
-                </a:solidFill>
-                <a:latin typeface="Aptos"/>
-              </a:rPr>
-              <a:t>MIT ACSC • ALANDI, PUNE</a:t>
-            </a:r>
-          </a:p>
-        </p:txBody>
-      </p:sp>
-      <p:sp>
-        <p:nvSpPr>
           <p:cNvPr id="3" name="TextBox 2">
             <a:extLst>
               <a:ext uri="{FF2B5EF4-FFF2-40B4-BE49-F238E27FC236}">
@@ -17061,36 +16263,6 @@
           </a:p>
         </p:txBody>
       </p:sp>
-      <p:pic>
-        <p:nvPicPr>
-          <p:cNvPr id="6" name="Picture 5">
-            <a:extLst>
-              <a:ext uri="{FF2B5EF4-FFF2-40B4-BE49-F238E27FC236}">
-                <a16:creationId xmlns:a16="http://schemas.microsoft.com/office/drawing/2014/main" id="{8A1211F6-F2DB-7378-C1DC-D150E4B005C0}"/>
-              </a:ext>
-            </a:extLst>
-          </p:cNvPr>
-          <p:cNvPicPr>
-            <a:picLocks noChangeAspect="1"/>
-          </p:cNvPicPr>
-          <p:nvPr/>
-        </p:nvPicPr>
-        <p:blipFill>
-          <a:blip r:embed="rId2"/>
-          <a:stretch>
-            <a:fillRect/>
-          </a:stretch>
-        </p:blipFill>
-        <p:spPr>
-          <a:xfrm>
-            <a:off x="11201014" y="64989"/>
-            <a:ext cx="884876" cy="894436"/>
-          </a:xfrm>
-          <a:prstGeom prst="rect">
-            <a:avLst/>
-          </a:prstGeom>
-        </p:spPr>
-      </p:pic>
       <p:sp>
         <p:nvSpPr>
           <p:cNvPr id="31" name="TextBox 30"/>
@@ -19633,36 +18805,6 @@
       </p:sp>
       <p:pic>
         <p:nvPicPr>
-          <p:cNvPr id="11" name="Picture 10">
-            <a:extLst>
-              <a:ext uri="{FF2B5EF4-FFF2-40B4-BE49-F238E27FC236}">
-                <a16:creationId xmlns:a16="http://schemas.microsoft.com/office/drawing/2014/main" id="{AAA16C95-DAEF-AD0D-C205-810A2820F698}"/>
-              </a:ext>
-            </a:extLst>
-          </p:cNvPr>
-          <p:cNvPicPr>
-            <a:picLocks noChangeAspect="1"/>
-          </p:cNvPicPr>
-          <p:nvPr/>
-        </p:nvPicPr>
-        <p:blipFill>
-          <a:blip r:embed="rId2"/>
-          <a:stretch>
-            <a:fillRect/>
-          </a:stretch>
-        </p:blipFill>
-        <p:spPr>
-          <a:xfrm>
-            <a:off x="11201014" y="64989"/>
-            <a:ext cx="884876" cy="894436"/>
-          </a:xfrm>
-          <a:prstGeom prst="rect">
-            <a:avLst/>
-          </a:prstGeom>
-        </p:spPr>
-      </p:pic>
-      <p:pic>
-        <p:nvPicPr>
           <p:cNvPr id="4" name="Picture 3">
             <a:extLst>
               <a:ext uri="{FF2B5EF4-FFF2-40B4-BE49-F238E27FC236}">
@@ -19676,7 +18818,7 @@
           <p:nvPr/>
         </p:nvPicPr>
         <p:blipFill>
-          <a:blip r:embed="rId3"/>
+          <a:blip r:embed="rId2"/>
           <a:stretch>
             <a:fillRect/>
           </a:stretch>
@@ -19933,36 +19075,6 @@
       </p:sp>
       <p:pic>
         <p:nvPicPr>
-          <p:cNvPr id="11" name="Picture 10">
-            <a:extLst>
-              <a:ext uri="{FF2B5EF4-FFF2-40B4-BE49-F238E27FC236}">
-                <a16:creationId xmlns:a16="http://schemas.microsoft.com/office/drawing/2014/main" id="{F93F716A-9408-AA10-65CA-9A1D30DFB85C}"/>
-              </a:ext>
-            </a:extLst>
-          </p:cNvPr>
-          <p:cNvPicPr>
-            <a:picLocks noChangeAspect="1"/>
-          </p:cNvPicPr>
-          <p:nvPr/>
-        </p:nvPicPr>
-        <p:blipFill>
-          <a:blip r:embed="rId2"/>
-          <a:stretch>
-            <a:fillRect/>
-          </a:stretch>
-        </p:blipFill>
-        <p:spPr>
-          <a:xfrm>
-            <a:off x="11201014" y="64989"/>
-            <a:ext cx="884876" cy="894436"/>
-          </a:xfrm>
-          <a:prstGeom prst="rect">
-            <a:avLst/>
-          </a:prstGeom>
-        </p:spPr>
-      </p:pic>
-      <p:pic>
-        <p:nvPicPr>
           <p:cNvPr id="4" name="Picture 3">
             <a:extLst>
               <a:ext uri="{FF2B5EF4-FFF2-40B4-BE49-F238E27FC236}">
@@ -19976,7 +19088,7 @@
           <p:nvPr/>
         </p:nvPicPr>
         <p:blipFill>
-          <a:blip r:embed="rId3"/>
+          <a:blip r:embed="rId2"/>
           <a:stretch>
             <a:fillRect/>
           </a:stretch>
@@ -20101,47 +19213,6 @@
       </p:sp>
       <p:sp>
         <p:nvSpPr>
-          <p:cNvPr id="9" name="TextBox 8">
-            <a:extLst>
-              <a:ext uri="{FF2B5EF4-FFF2-40B4-BE49-F238E27FC236}">
-                <a16:creationId xmlns:a16="http://schemas.microsoft.com/office/drawing/2014/main" id="{89125392-F7F2-4102-4866-DE18AB4C2BD7}"/>
-              </a:ext>
-            </a:extLst>
-          </p:cNvPr>
-          <p:cNvSpPr txBox="1"/>
-          <p:nvPr/>
-        </p:nvSpPr>
-        <p:spPr>
-          <a:xfrm>
-            <a:off x="10067449" y="6348414"/>
-            <a:ext cx="1680211" cy="584775"/>
-          </a:xfrm>
-          <a:prstGeom prst="rect">
-            <a:avLst/>
-          </a:prstGeom>
-          <a:noFill/>
-        </p:spPr>
-        <p:txBody>
-          <a:bodyPr wrap="square" lIns="45720" rIns="45720">
-            <a:spAutoFit/>
-          </a:bodyPr>
-          <a:lstStyle/>
-          <a:p>
-            <a:pPr algn="r"/>
-            <a:r>
-              <a:rPr sz="1600" b="1" dirty="0">
-                <a:solidFill>
-                  <a:srgbClr val="F5EBD2"/>
-                </a:solidFill>
-                <a:latin typeface="Aptos"/>
-              </a:rPr>
-              <a:t>MIT ACSC • ALANDI, PUNE</a:t>
-            </a:r>
-          </a:p>
-        </p:txBody>
-      </p:sp>
-      <p:sp>
-        <p:nvSpPr>
           <p:cNvPr id="3" name="TextBox 2">
             <a:extLst>
               <a:ext uri="{FF2B5EF4-FFF2-40B4-BE49-F238E27FC236}">
@@ -20236,36 +19307,6 @@
           </a:p>
         </p:txBody>
       </p:sp>
-      <p:pic>
-        <p:nvPicPr>
-          <p:cNvPr id="6" name="Picture 5">
-            <a:extLst>
-              <a:ext uri="{FF2B5EF4-FFF2-40B4-BE49-F238E27FC236}">
-                <a16:creationId xmlns:a16="http://schemas.microsoft.com/office/drawing/2014/main" id="{2D1F8CB6-6FFA-F8C3-6855-525C5321A4DC}"/>
-              </a:ext>
-            </a:extLst>
-          </p:cNvPr>
-          <p:cNvPicPr>
-            <a:picLocks noChangeAspect="1"/>
-          </p:cNvPicPr>
-          <p:nvPr/>
-        </p:nvPicPr>
-        <p:blipFill>
-          <a:blip r:embed="rId2"/>
-          <a:stretch>
-            <a:fillRect/>
-          </a:stretch>
-        </p:blipFill>
-        <p:spPr>
-          <a:xfrm>
-            <a:off x="11201014" y="64989"/>
-            <a:ext cx="884876" cy="894436"/>
-          </a:xfrm>
-          <a:prstGeom prst="rect">
-            <a:avLst/>
-          </a:prstGeom>
-        </p:spPr>
-      </p:pic>
       <p:sp>
         <p:nvSpPr>
           <p:cNvPr id="31" name="TextBox 30"/>
@@ -22206,47 +21247,6 @@
       </p:sp>
       <p:sp>
         <p:nvSpPr>
-          <p:cNvPr id="9" name="TextBox 8">
-            <a:extLst>
-              <a:ext uri="{FF2B5EF4-FFF2-40B4-BE49-F238E27FC236}">
-                <a16:creationId xmlns:a16="http://schemas.microsoft.com/office/drawing/2014/main" id="{7FBCB2C2-7BC0-8899-F531-910ADC138B22}"/>
-              </a:ext>
-            </a:extLst>
-          </p:cNvPr>
-          <p:cNvSpPr txBox="1"/>
-          <p:nvPr/>
-        </p:nvSpPr>
-        <p:spPr>
-          <a:xfrm>
-            <a:off x="10067449" y="6348414"/>
-            <a:ext cx="1680211" cy="461665"/>
-          </a:xfrm>
-          <a:prstGeom prst="rect">
-            <a:avLst/>
-          </a:prstGeom>
-          <a:noFill/>
-        </p:spPr>
-        <p:txBody>
-          <a:bodyPr wrap="square" lIns="45720" rIns="45720">
-            <a:spAutoFit/>
-          </a:bodyPr>
-          <a:lstStyle/>
-          <a:p>
-            <a:pPr algn="r"/>
-            <a:r>
-              <a:rPr sz="1200" b="1" dirty="0">
-                <a:solidFill>
-                  <a:srgbClr val="F5EBD2"/>
-                </a:solidFill>
-                <a:latin typeface="Aptos"/>
-              </a:rPr>
-              <a:t>MIT ACSC • ALANDI, PUNE</a:t>
-            </a:r>
-          </a:p>
-        </p:txBody>
-      </p:sp>
-      <p:sp>
-        <p:nvSpPr>
           <p:cNvPr id="3" name="TextBox 2">
             <a:extLst>
               <a:ext uri="{FF2B5EF4-FFF2-40B4-BE49-F238E27FC236}">
@@ -22330,36 +21330,6 @@
           </a:p>
         </p:txBody>
       </p:sp>
-      <p:pic>
-        <p:nvPicPr>
-          <p:cNvPr id="13" name="Picture 12">
-            <a:extLst>
-              <a:ext uri="{FF2B5EF4-FFF2-40B4-BE49-F238E27FC236}">
-                <a16:creationId xmlns:a16="http://schemas.microsoft.com/office/drawing/2014/main" id="{8423B074-A13C-A600-A8DC-E529C45BF03B}"/>
-              </a:ext>
-            </a:extLst>
-          </p:cNvPr>
-          <p:cNvPicPr>
-            <a:picLocks noChangeAspect="1"/>
-          </p:cNvPicPr>
-          <p:nvPr/>
-        </p:nvPicPr>
-        <p:blipFill>
-          <a:blip r:embed="rId2"/>
-          <a:stretch>
-            <a:fillRect/>
-          </a:stretch>
-        </p:blipFill>
-        <p:spPr>
-          <a:xfrm>
-            <a:off x="11201014" y="64989"/>
-            <a:ext cx="884876" cy="894436"/>
-          </a:xfrm>
-          <a:prstGeom prst="rect">
-            <a:avLst/>
-          </a:prstGeom>
-        </p:spPr>
-      </p:pic>
       <p:sp>
         <p:nvSpPr>
           <p:cNvPr id="31" name="TextBox 30"/>
@@ -22408,7 +21378,7 @@
         <p:spPr>
           <a:xfrm>
             <a:off x="640080" y="585216"/>
-            <a:ext cx="10881360" cy="603504"/>
+            <a:ext cx="10881360" cy="477054"/>
           </a:xfrm>
           <a:prstGeom prst="rect">
             <a:avLst/>
@@ -22427,14 +21397,20 @@
               </a:spcAft>
             </a:pPr>
             <a:r>
-              <a:rPr sz="3100" b="1">
+              <a:rPr lang="en-IN" sz="3100" b="1" dirty="0">
                 <a:solidFill>
                   <a:srgbClr val="14191C"/>
                 </a:solidFill>
                 <a:latin typeface="Cambria"/>
               </a:rPr>
-              <a:t>Why This Is Actually Agentic</a:t>
-            </a:r>
+              <a:t>Scalability</a:t>
+            </a:r>
+            <a:endParaRPr sz="3100" b="1" dirty="0">
+              <a:solidFill>
+                <a:srgbClr val="14191C"/>
+              </a:solidFill>
+              <a:latin typeface="Cambria"/>
+            </a:endParaRPr>
           </a:p>
         </p:txBody>
       </p:sp>

</xml_diff>